<commit_message>
Rebuild the deck with the learned-heuristic slide
52 slides. Adds 'Onde o aprendizado de maquina ENTRARIA: a heuristica' to topic
3, contrasting why learning the heuristic is a different task from learning the
diagnosis - free, exact supervision from uniform-cost search - against what
actually blocks it, which is admissibility rather than data.
</commit_message>
<xml_diff>
--- a/docs/presentation/ai-for-smartgrids-apresentacao.pptx
+++ b/docs/presentation/ai-for-smartgrids-apresentacao.pptx
@@ -56,6 +56,7 @@
     <p:sldId id="304" r:id="rId56"/>
     <p:sldId id="305" r:id="rId57"/>
     <p:sldId id="306" r:id="rId58"/>
+    <p:sldId id="307" r:id="rId59"/>
   </p:sldIdLst>
   <p:sldSz cx="12191695" cy="6858000" type="screen4x3"/>
   <p:notesSz cx="6858000" cy="9144000"/>
@@ -3740,7 +3741,22 @@
           <a:lstStyle/>
           <a:p>
             <a:r>
-              <a:t>Este é o argumento mais forte da apresentação inteira. Não o apresse.</a:t>
+              <a:t>Este é o argumento mais forte da apresentação — mas repare no escopo do</a:t>
+            </a:r>
+          </a:p>
+          <a:p>
+            <a:r>
+              <a:t>título: DIAGNÓSTICO. Não diga "não usamos aprendizado de máquina" como se valesse</a:t>
+            </a:r>
+          </a:p>
+          <a:p>
+            <a:r>
+              <a:t>para os três sistemas; a afirmação é sobre a tarefa de classificar a causa de uma</a:t>
+            </a:r>
+          </a:p>
+          <a:p>
+            <a:r>
+              <a:t>falha, e só sobre ela.</a:t>
             </a:r>
           </a:p>
           <a:p/>
@@ -3761,18 +3777,33 @@
           </a:p>
           <a:p>
             <a:r>
-              <a:t>qual comparar. Sem as duas, nenhum rótulo vem de medição.</a:t>
+              <a:t>qual comparar. Sem as duas, nenhum rótulo vem de medição. E um modelo treinado</a:t>
+            </a:r>
+          </a:p>
+          <a:p>
+            <a:r>
+              <a:t>apenas em estado normal não infere degradação de modo confiável — ele nunca viu</a:t>
+            </a:r>
+          </a:p>
+          <a:p>
+            <a:r>
+              <a:t>a classe que deveria reconhecer.</a:t>
             </a:r>
           </a:p>
           <a:p/>
           <a:p>
             <a:r>
-              <a:t>E um modelo treinado apenas em estado normal não infere degradação de modo</a:t>
-            </a:r>
-          </a:p>
-          <a:p>
-            <a:r>
-              <a:t>confiável — ele nunca viu a classe que deveria reconhecer.</a:t>
+              <a:t>Se alguém perguntar "e aprender a heurística da busca?", a resposta é que essa é</a:t>
+            </a:r>
+          </a:p>
+          <a:p>
+            <a:r>
+              <a:t>uma tarefa DIFERENTE, com supervisão gratuita — e temos um slide sobre ela no</a:t>
+            </a:r>
+          </a:p>
+          <a:p>
+            <a:r>
+              <a:t>tema 3.</a:t>
             </a:r>
           </a:p>
         </p:txBody>
@@ -4475,40 +4506,91 @@
           <a:lstStyle/>
           <a:p>
             <a:r>
-              <a:t>Feche o tema 3 amarrando-o ao tema 2.</a:t>
+              <a:t>Este slide existe porque a pergunta é boa e vai ser feita.</a:t>
             </a:r>
           </a:p>
           <a:p/>
           <a:p>
             <a:r>
-              <a:t>A busca está definida sobre um PROBLEMA ABSTRATO: estado inicial, teste de</a:t>
-            </a:r>
-          </a:p>
-          <a:p>
-            <a:r>
-              <a:t>objetivo, função sucessora. Nada nela sabe o que é um nó de rede.</a:t>
+              <a:t>Aprender a heurística NÃO esbarra no obstáculo do diagnóstico. O alvo de</a:t>
+            </a:r>
+          </a:p>
+          <a:p>
+            <a:r>
+              <a:t>regressão é o custo real restante, e esse custo é calculável exatamente rodando</a:t>
+            </a:r>
+          </a:p>
+          <a:p>
+            <a:r>
+              <a:t>Dijkstra a partir do objetivo. A supervisão é gratuita, exata e ilimitada — nada</a:t>
+            </a:r>
+          </a:p>
+          <a:p>
+            <a:r>
+              <a:t>a ver com rotular falhas em campo.</a:t>
             </a:r>
           </a:p>
           <a:p/>
           <a:p>
             <a:r>
-              <a:t>Por isso a mesma função serve para achar um caminho num grafo de comunicação e</a:t>
-            </a:r>
-          </a:p>
-          <a:p>
-            <a:r>
-              <a:t>para achar uma sequência de ações num espaço de estados de planejamento. Não há</a:t>
-            </a:r>
-          </a:p>
-          <a:p>
-            <a:r>
-              <a:t>duas implementações de A* neste repositório — há uma, usada duas vezes.</a:t>
+              <a:t>O ponto onde isso realmente pagaria não é o roteamento: ali a distância em linha</a:t>
+            </a:r>
+          </a:p>
+          <a:p>
+            <a:r>
+              <a:t>reta já é quase perfeita e custa nada. É o PLANEJADOR, onde goal_count vale no</a:t>
+            </a:r>
+          </a:p>
+          <a:p>
+            <a:r>
+              <a:t>máximo 2 e o espaço de estados não tem geometria para explorar. É exatamente o</a:t>
+            </a:r>
+          </a:p>
+          <a:p>
+            <a:r>
+              <a:t>caso em que a literatura usa heurísticas aprendidas.</a:t>
             </a:r>
           </a:p>
           <a:p/>
           <a:p>
             <a:r>
-              <a:t>É o tipo de reuso que só aparece quando a abstração está certa.</a:t>
+              <a:t>O preço é a admissibilidade. Uma rede treinada por regressão pode superestimar, e</a:t>
+            </a:r>
+          </a:p>
+          <a:p>
+            <a:r>
+              <a:t>aí o A* continua rodando e devolve planos subótimos SEM AVISAR — o mesmo risco</a:t>
+            </a:r>
+          </a:p>
+          <a:p>
+            <a:r>
+              <a:t>que discutimos no slide da heurística goal_count.</a:t>
+            </a:r>
+          </a:p>
+          <a:p/>
+          <a:p>
+            <a:r>
+              <a:t>E aqui está o que torna este repositório bem posicionado para o experimento: já</a:t>
+            </a:r>
+          </a:p>
+          <a:p>
+            <a:r>
+              <a:t>temos testes que verificam admissibilidade exaustivamente. Eles nao seriam</a:t>
+            </a:r>
+          </a:p>
+          <a:p>
+            <a:r>
+              <a:t>apenas uma proteção — seriam o instrumento para MEDIR quantas vezes a heurística</a:t>
+            </a:r>
+          </a:p>
+          <a:p>
+            <a:r>
+              <a:t>aprendida viola a admissibilidade, e em quanto. Isso é um resultado publicável,</a:t>
+            </a:r>
+          </a:p>
+          <a:p>
+            <a:r>
+              <a:t>não um detalhe de implementação.</a:t>
             </a:r>
           </a:p>
         </p:txBody>
@@ -4578,34 +4660,40 @@
           <a:lstStyle/>
           <a:p>
             <a:r>
-              <a:t>Último bloco, e o único em que os três trabalhos aparecem juntos.</a:t>
+              <a:t>Feche o tema 3 amarrando-o ao tema 2.</a:t>
             </a:r>
           </a:p>
           <a:p/>
           <a:p>
             <a:r>
-              <a:t>Até aqui cada tema foi apresentado isoladamente. Agora mostre que eles formam um</a:t>
-            </a:r>
-          </a:p>
-          <a:p>
-            <a:r>
-              <a:t>sistema: um incidente atravessa os três, e o que sai de um é a entrada do</a:t>
-            </a:r>
-          </a:p>
-          <a:p>
-            <a:r>
-              <a:t>seguinte.</a:t>
+              <a:t>A busca está definida sobre um PROBLEMA ABSTRATO: estado inicial, teste de</a:t>
+            </a:r>
+          </a:p>
+          <a:p>
+            <a:r>
+              <a:t>objetivo, função sucessora. Nada nela sabe o que é um nó de rede.</a:t>
             </a:r>
           </a:p>
           <a:p/>
           <a:p>
             <a:r>
-              <a:t>Reserve tempo para as perguntas — com três temas de trinta minutos, elas tendem</a:t>
-            </a:r>
-          </a:p>
-          <a:p>
-            <a:r>
-              <a:t>a concentrar-se no fim.</a:t>
+              <a:t>Por isso a mesma função serve para achar um caminho num grafo de comunicação e</a:t>
+            </a:r>
+          </a:p>
+          <a:p>
+            <a:r>
+              <a:t>para achar uma sequência de ações num espaço de estados de planejamento. Não há</a:t>
+            </a:r>
+          </a:p>
+          <a:p>
+            <a:r>
+              <a:t>duas implementações de A* neste repositório — há uma, usada duas vezes.</a:t>
+            </a:r>
+          </a:p>
+          <a:p/>
+          <a:p>
+            <a:r>
+              <a:t>É o tipo de reuso que só aparece quando a abstração está certa.</a:t>
             </a:r>
           </a:p>
         </p:txBody>
@@ -4675,34 +4763,34 @@
           <a:lstStyle/>
           <a:p>
             <a:r>
-              <a:t>A demonstração final. Um comando só.</a:t>
+              <a:t>Último bloco, e o único em que os três trabalhos aparecem juntos.</a:t>
             </a:r>
           </a:p>
           <a:p/>
           <a:p>
             <a:r>
-              <a:t>O sistema especialista diagnostica congestionamento. O diagnóstico vira o estado</a:t>
-            </a:r>
-          </a:p>
-          <a:p>
-            <a:r>
-              <a:t>inicial do planejador. O planejador só pode propor desvio porque a busca A*</a:t>
-            </a:r>
-          </a:p>
-          <a:p>
-            <a:r>
-              <a:t>CONFIRMOU que existe rota alternativa evitando o nó. E o plano sai com</a:t>
-            </a:r>
-          </a:p>
-          <a:p>
-            <a:r>
-              <a:t>autorização, verificação e registro.</a:t>
+              <a:t>Até aqui cada tema foi apresentado isoladamente. Agora mostre que eles formam um</a:t>
+            </a:r>
+          </a:p>
+          <a:p>
+            <a:r>
+              <a:t>sistema: um incidente atravessa os três, e o que sai de um é a entrada do</a:t>
+            </a:r>
+          </a:p>
+          <a:p>
+            <a:r>
+              <a:t>seguinte.</a:t>
             </a:r>
           </a:p>
           <a:p/>
           <a:p>
             <a:r>
-              <a:t>Os três trabalhos não são três exercícios: são um sistema.</a:t>
+              <a:t>Reserve tempo para as perguntas — com três temas de trinta minutos, elas tendem</a:t>
+            </a:r>
+          </a:p>
+          <a:p>
+            <a:r>
+              <a:t>a concentrar-se no fim.</a:t>
             </a:r>
           </a:p>
         </p:txBody>
@@ -4772,34 +4860,34 @@
           <a:lstStyle/>
           <a:p>
             <a:r>
-              <a:t>Feche pelos limites, e não pelos resultados. É o que separa um trabalho de</a:t>
-            </a:r>
-          </a:p>
-          <a:p>
-            <a:r>
-              <a:t>engenharia de uma demonstração.</a:t>
+              <a:t>A demonstração final. Um comando só.</a:t>
             </a:r>
           </a:p>
           <a:p/>
           <a:p>
             <a:r>
-              <a:t>Cada uma destas linhas é uma afirmação que o sistema faz sobre si mesmo — a</a:t>
-            </a:r>
-          </a:p>
-          <a:p>
-            <a:r>
-              <a:t>última aparece impressa ao fim de cada consulta.</a:t>
+              <a:t>O sistema especialista diagnostica congestionamento. O diagnóstico vira o estado</a:t>
+            </a:r>
+          </a:p>
+          <a:p>
+            <a:r>
+              <a:t>inicial do planejador. O planejador só pode propor desvio porque a busca A*</a:t>
+            </a:r>
+          </a:p>
+          <a:p>
+            <a:r>
+              <a:t>CONFIRMOU que existe rota alternativa evitando o nó. E o plano sai com</a:t>
+            </a:r>
+          </a:p>
+          <a:p>
+            <a:r>
+              <a:t>autorização, verificação e registro.</a:t>
             </a:r>
           </a:p>
           <a:p/>
           <a:p>
             <a:r>
-              <a:t>Se houver tempo, mencione o que vem a seguir: o sistema multiespecialista e a</a:t>
-            </a:r>
-          </a:p>
-          <a:p>
-            <a:r>
-              <a:t>eco-resolução em 25/09, e a análise do artigo sobre encadeamento em 02/10.</a:t>
+              <a:t>Os três trabalhos não são três exercícios: são um sistema.</a:t>
             </a:r>
           </a:p>
         </p:txBody>
@@ -4971,23 +5059,34 @@
           <a:lstStyle/>
           <a:p>
             <a:r>
-              <a:t>Não mostre este slide na apresentação — ele é a sua cola. Deixe-o oculto ou</a:t>
-            </a:r>
-          </a:p>
-          <a:p>
-            <a:r>
-              <a:t>pule-o rapidamente.</a:t>
+              <a:t>Feche pelos limites, e não pelos resultados. É o que separa um trabalho de</a:t>
+            </a:r>
+          </a:p>
+          <a:p>
+            <a:r>
+              <a:t>engenharia de uma demonstração.</a:t>
             </a:r>
           </a:p>
           <a:p/>
           <a:p>
             <a:r>
-              <a:t>Se uma pergunta não estiver aqui e você não souber, a melhor resposta é a</a:t>
-            </a:r>
-          </a:p>
-          <a:p>
-            <a:r>
-              <a:t>honesta: dizer o que sabe, dizer o que não verificou, e oferecer verificar.</a:t>
+              <a:t>Cada uma destas linhas é uma afirmação que o sistema faz sobre si mesmo — a</a:t>
+            </a:r>
+          </a:p>
+          <a:p>
+            <a:r>
+              <a:t>última aparece impressa ao fim de cada consulta.</a:t>
+            </a:r>
+          </a:p>
+          <a:p/>
+          <a:p>
+            <a:r>
+              <a:t>Se houver tempo, mencione o que vem a seguir: o sistema multiespecialista e a</a:t>
+            </a:r>
+          </a:p>
+          <a:p>
+            <a:r>
+              <a:t>eco-resolução em 25/09, e a análise do artigo sobre encadeamento em 02/10.</a:t>
             </a:r>
           </a:p>
         </p:txBody>
@@ -5013,6 +5112,92 @@
 </file>
 
 <file path=ppt/notesSlides/notesSlide51.xml><?xml version="1.0" encoding="utf-8"?>
+<p:notes xmlns:a="http://schemas.openxmlformats.org/drawingml/2006/main" xmlns:p="http://schemas.openxmlformats.org/presentationml/2006/main" xmlns:r="http://schemas.openxmlformats.org/officeDocument/2006/relationships">
+  <p:cSld>
+    <p:spTree>
+      <p:nvGrpSpPr>
+        <p:cNvPr id="1" name=""/>
+        <p:cNvGrpSpPr/>
+        <p:nvPr/>
+      </p:nvGrpSpPr>
+      <p:grpSpPr>
+        <a:xfrm>
+          <a:off x="0" y="0"/>
+          <a:ext cx="0" cy="0"/>
+          <a:chOff x="0" y="0"/>
+          <a:chExt cx="0" cy="0"/>
+        </a:xfrm>
+      </p:grpSpPr>
+      <p:sp>
+        <p:nvSpPr>
+          <p:cNvPr id="2" name="Slide Image Placeholder 1"/>
+          <p:cNvSpPr>
+            <a:spLocks noGrp="1"/>
+          </p:cNvSpPr>
+          <p:nvPr>
+            <p:ph type="sldImg" idx="2"/>
+          </p:nvPr>
+        </p:nvSpPr>
+        <p:spPr/>
+      </p:sp>
+      <p:sp>
+        <p:nvSpPr>
+          <p:cNvPr id="3" name="Notes Placeholder 2"/>
+          <p:cNvSpPr>
+            <a:spLocks noGrp="1"/>
+          </p:cNvSpPr>
+          <p:nvPr>
+            <p:ph type="body" idx="3" sz="quarter"/>
+          </p:nvPr>
+        </p:nvSpPr>
+        <p:spPr/>
+        <p:txBody>
+          <a:bodyPr/>
+          <a:lstStyle/>
+          <a:p>
+            <a:r>
+              <a:t>Não mostre este slide na apresentação — ele é a sua cola. Deixe-o oculto ou</a:t>
+            </a:r>
+          </a:p>
+          <a:p>
+            <a:r>
+              <a:t>pule-o rapidamente.</a:t>
+            </a:r>
+          </a:p>
+          <a:p/>
+          <a:p>
+            <a:r>
+              <a:t>Se uma pergunta não estiver aqui e você não souber, a melhor resposta é a</a:t>
+            </a:r>
+          </a:p>
+          <a:p>
+            <a:r>
+              <a:t>honesta: dizer o que sabe, dizer o que não verificou, e oferecer verificar.</a:t>
+            </a:r>
+          </a:p>
+        </p:txBody>
+      </p:sp>
+      <p:sp>
+        <p:nvSpPr>
+          <p:cNvPr id="4" name="Slide Number Placeholder 3"/>
+          <p:cNvSpPr>
+            <a:spLocks noGrp="1"/>
+          </p:cNvSpPr>
+          <p:nvPr>
+            <p:ph type="sldNum" idx="5" sz="quarter"/>
+          </p:nvPr>
+        </p:nvSpPr>
+        <p:spPr/>
+      </p:sp>
+    </p:spTree>
+  </p:cSld>
+  <p:clrMapOvr>
+    <a:masterClrMapping/>
+  </p:clrMapOvr>
+</p:notes>
+</file>
+
+<file path=ppt/notesSlides/notesSlide52.xml><?xml version="1.0" encoding="utf-8"?>
 <p:notes xmlns:a="http://schemas.openxmlformats.org/drawingml/2006/main" xmlns:p="http://schemas.openxmlformats.org/presentationml/2006/main" xmlns:r="http://schemas.openxmlformats.org/officeDocument/2006/relationships">
   <p:cSld>
     <p:spTree>
@@ -19461,7 +19646,7 @@
                 </a:solidFill>
                 <a:latin typeface="Segoe UI"/>
               </a:rPr>
-              <a:t>Por que sistemas simbólicos, e não aprendizado de máquina?</a:t>
+              <a:t>Por que o DIAGNÓSTICO não é aprendido?</a:t>
             </a:r>
           </a:p>
         </p:txBody>
@@ -22230,6 +22415,523 @@
             <a:avLst/>
           </a:prstGeom>
           <a:solidFill>
+            <a:srgbClr val="FBFAF7"/>
+          </a:solidFill>
+          <a:ln>
+            <a:noFill/>
+          </a:ln>
+          <a:effectLst/>
+        </p:spPr>
+        <p:style>
+          <a:lnRef idx="1">
+            <a:schemeClr val="accent1"/>
+          </a:lnRef>
+          <a:fillRef idx="3">
+            <a:schemeClr val="accent1"/>
+          </a:fillRef>
+          <a:effectRef idx="2">
+            <a:schemeClr val="accent1"/>
+          </a:effectRef>
+          <a:fontRef idx="minor">
+            <a:schemeClr val="lt1"/>
+          </a:fontRef>
+        </p:style>
+        <p:txBody>
+          <a:bodyPr rtlCol="0" anchor="ctr"/>
+          <a:lstStyle/>
+          <a:p>
+            <a:pPr algn="ctr"/>
+          </a:p>
+        </p:txBody>
+      </p:sp>
+      <p:sp>
+        <p:nvSpPr>
+          <p:cNvPr id="3" name="Rectangle 2"/>
+          <p:cNvSpPr/>
+          <p:nvPr/>
+        </p:nvSpPr>
+        <p:spPr>
+          <a:xfrm>
+            <a:off x="0" y="0"/>
+            <a:ext cx="12191695" cy="146304"/>
+          </a:xfrm>
+          <a:prstGeom prst="rect">
+            <a:avLst/>
+          </a:prstGeom>
+          <a:solidFill>
+            <a:srgbClr val="E69F00"/>
+          </a:solidFill>
+          <a:ln>
+            <a:noFill/>
+          </a:ln>
+          <a:effectLst/>
+        </p:spPr>
+        <p:style>
+          <a:lnRef idx="1">
+            <a:schemeClr val="accent1"/>
+          </a:lnRef>
+          <a:fillRef idx="3">
+            <a:schemeClr val="accent1"/>
+          </a:fillRef>
+          <a:effectRef idx="2">
+            <a:schemeClr val="accent1"/>
+          </a:effectRef>
+          <a:fontRef idx="minor">
+            <a:schemeClr val="lt1"/>
+          </a:fontRef>
+        </p:style>
+        <p:txBody>
+          <a:bodyPr rtlCol="0" anchor="ctr"/>
+          <a:lstStyle/>
+          <a:p>
+            <a:pPr algn="ctr"/>
+          </a:p>
+        </p:txBody>
+      </p:sp>
+      <p:sp>
+        <p:nvSpPr>
+          <p:cNvPr id="4" name="TextBox 3"/>
+          <p:cNvSpPr txBox="1"/>
+          <p:nvPr/>
+        </p:nvSpPr>
+        <p:spPr>
+          <a:xfrm>
+            <a:off x="685800" y="384048"/>
+            <a:ext cx="10789920" cy="731520"/>
+          </a:xfrm>
+          <a:prstGeom prst="rect">
+            <a:avLst/>
+          </a:prstGeom>
+          <a:noFill/>
+        </p:spPr>
+        <p:txBody>
+          <a:bodyPr wrap="square">
+            <a:spAutoFit/>
+          </a:bodyPr>
+          <a:lstStyle/>
+          <a:p>
+            <a:pPr algn="l">
+              <a:lnSpc>
+                <a:spcPct val="100000"/>
+              </a:lnSpc>
+            </a:pPr>
+            <a:r>
+              <a:rPr sz="3000" b="1">
+                <a:solidFill>
+                  <a:srgbClr val="1F2933"/>
+                </a:solidFill>
+                <a:latin typeface="Segoe UI"/>
+              </a:rPr>
+              <a:t>Onde o aprendizado de máquina ENTRARIA: a heurística</a:t>
+            </a:r>
+          </a:p>
+        </p:txBody>
+      </p:sp>
+      <p:sp>
+        <p:nvSpPr>
+          <p:cNvPr id="5" name="Rectangle 4"/>
+          <p:cNvSpPr/>
+          <p:nvPr/>
+        </p:nvSpPr>
+        <p:spPr>
+          <a:xfrm>
+            <a:off x="685800" y="1325880"/>
+            <a:ext cx="5120640" cy="4572000"/>
+          </a:xfrm>
+          <a:prstGeom prst="rect">
+            <a:avLst/>
+          </a:prstGeom>
+          <a:solidFill>
+            <a:srgbClr val="FFFFFF"/>
+          </a:solidFill>
+          <a:ln w="22225">
+            <a:solidFill>
+              <a:srgbClr val="009E73"/>
+            </a:solidFill>
+          </a:ln>
+          <a:effectLst/>
+        </p:spPr>
+        <p:style>
+          <a:lnRef idx="1">
+            <a:schemeClr val="accent1"/>
+          </a:lnRef>
+          <a:fillRef idx="3">
+            <a:schemeClr val="accent1"/>
+          </a:fillRef>
+          <a:effectRef idx="2">
+            <a:schemeClr val="accent1"/>
+          </a:effectRef>
+          <a:fontRef idx="minor">
+            <a:schemeClr val="lt1"/>
+          </a:fontRef>
+        </p:style>
+        <p:txBody>
+          <a:bodyPr rtlCol="0" anchor="ctr"/>
+          <a:lstStyle/>
+          <a:p/>
+        </p:txBody>
+      </p:sp>
+      <p:sp>
+        <p:nvSpPr>
+          <p:cNvPr id="6" name="TextBox 5"/>
+          <p:cNvSpPr txBox="1"/>
+          <p:nvPr/>
+        </p:nvSpPr>
+        <p:spPr>
+          <a:xfrm>
+            <a:off x="960120" y="1508760"/>
+            <a:ext cx="4572000" cy="457200"/>
+          </a:xfrm>
+          <a:prstGeom prst="rect">
+            <a:avLst/>
+          </a:prstGeom>
+          <a:noFill/>
+        </p:spPr>
+        <p:txBody>
+          <a:bodyPr wrap="square">
+            <a:spAutoFit/>
+          </a:bodyPr>
+          <a:lstStyle/>
+          <a:p>
+            <a:pPr algn="l">
+              <a:lnSpc>
+                <a:spcPct val="100000"/>
+              </a:lnSpc>
+            </a:pPr>
+            <a:r>
+              <a:rPr sz="1900" b="1">
+                <a:solidFill>
+                  <a:srgbClr val="009E73"/>
+                </a:solidFill>
+                <a:latin typeface="Segoe UI"/>
+              </a:rPr>
+              <a:t>Por que é uma tarefa diferente</a:t>
+            </a:r>
+          </a:p>
+        </p:txBody>
+      </p:sp>
+      <p:sp>
+        <p:nvSpPr>
+          <p:cNvPr id="7" name="TextBox 6"/>
+          <p:cNvSpPr txBox="1"/>
+          <p:nvPr/>
+        </p:nvSpPr>
+        <p:spPr>
+          <a:xfrm>
+            <a:off x="960120" y="2057400"/>
+            <a:ext cx="4572000" cy="3657600"/>
+          </a:xfrm>
+          <a:prstGeom prst="rect">
+            <a:avLst/>
+          </a:prstGeom>
+          <a:noFill/>
+        </p:spPr>
+        <p:txBody>
+          <a:bodyPr wrap="square">
+            <a:spAutoFit/>
+          </a:bodyPr>
+          <a:lstStyle/>
+          <a:p>
+            <a:pPr>
+              <a:spcAft>
+                <a:spcPts val="1000"/>
+              </a:spcAft>
+            </a:pPr>
+            <a:r>
+              <a:rPr sz="1600">
+                <a:solidFill>
+                  <a:srgbClr val="52606D"/>
+                </a:solidFill>
+                <a:latin typeface="Segoe UI"/>
+              </a:rPr>
+              <a:t>O alvo é h*(n), o custo real restante</a:t>
+            </a:r>
+          </a:p>
+          <a:p>
+            <a:pPr>
+              <a:spcAft>
+                <a:spcPts val="1000"/>
+              </a:spcAft>
+            </a:pPr>
+            <a:r>
+              <a:rPr sz="1600">
+                <a:solidFill>
+                  <a:srgbClr val="52606D"/>
+                </a:solidFill>
+                <a:latin typeface="Segoe UI"/>
+              </a:rPr>
+              <a:t>Calculável exatamente: Dijkstra a partir do objetivo</a:t>
+            </a:r>
+          </a:p>
+          <a:p>
+            <a:pPr>
+              <a:spcAft>
+                <a:spcPts val="1000"/>
+              </a:spcAft>
+            </a:pPr>
+            <a:r>
+              <a:rPr sz="1600">
+                <a:solidFill>
+                  <a:srgbClr val="52606D"/>
+                </a:solidFill>
+                <a:latin typeface="Segoe UI"/>
+              </a:rPr>
+              <a:t>Supervisão gratuita e exata — não é rótulo de falha</a:t>
+            </a:r>
+          </a:p>
+          <a:p>
+            <a:pPr>
+              <a:spcAft>
+                <a:spcPts val="1000"/>
+              </a:spcAft>
+            </a:pPr>
+            <a:r>
+              <a:rPr sz="1600">
+                <a:solidFill>
+                  <a:srgbClr val="52606D"/>
+                </a:solidFill>
+                <a:latin typeface="Segoe UI"/>
+              </a:rPr>
+              <a:t>Não exige instrumento de degradação nem campo</a:t>
+            </a:r>
+          </a:p>
+          <a:p>
+            <a:pPr>
+              <a:spcAft>
+                <a:spcPts val="1000"/>
+              </a:spcAft>
+            </a:pPr>
+            <a:r>
+              <a:rPr sz="1600">
+                <a:solidFill>
+                  <a:srgbClr val="52606D"/>
+                </a:solidFill>
+                <a:latin typeface="Segoe UI"/>
+              </a:rPr>
+              <a:t>Vale mais no PLANEJADOR: goal_count é fraca e o espaço não tem geometria</a:t>
+            </a:r>
+          </a:p>
+        </p:txBody>
+      </p:sp>
+      <p:sp>
+        <p:nvSpPr>
+          <p:cNvPr id="8" name="Rectangle 7"/>
+          <p:cNvSpPr/>
+          <p:nvPr/>
+        </p:nvSpPr>
+        <p:spPr>
+          <a:xfrm>
+            <a:off x="6355080" y="1325880"/>
+            <a:ext cx="5120640" cy="4572000"/>
+          </a:xfrm>
+          <a:prstGeom prst="rect">
+            <a:avLst/>
+          </a:prstGeom>
+          <a:solidFill>
+            <a:srgbClr val="FFFFFF"/>
+          </a:solidFill>
+          <a:ln w="22225">
+            <a:solidFill>
+              <a:srgbClr val="D55E00"/>
+            </a:solidFill>
+          </a:ln>
+          <a:effectLst/>
+        </p:spPr>
+        <p:style>
+          <a:lnRef idx="1">
+            <a:schemeClr val="accent1"/>
+          </a:lnRef>
+          <a:fillRef idx="3">
+            <a:schemeClr val="accent1"/>
+          </a:fillRef>
+          <a:effectRef idx="2">
+            <a:schemeClr val="accent1"/>
+          </a:effectRef>
+          <a:fontRef idx="minor">
+            <a:schemeClr val="lt1"/>
+          </a:fontRef>
+        </p:style>
+        <p:txBody>
+          <a:bodyPr rtlCol="0" anchor="ctr"/>
+          <a:lstStyle/>
+          <a:p/>
+        </p:txBody>
+      </p:sp>
+      <p:sp>
+        <p:nvSpPr>
+          <p:cNvPr id="9" name="TextBox 8"/>
+          <p:cNvSpPr txBox="1"/>
+          <p:nvPr/>
+        </p:nvSpPr>
+        <p:spPr>
+          <a:xfrm>
+            <a:off x="6629400" y="1508760"/>
+            <a:ext cx="4572000" cy="457200"/>
+          </a:xfrm>
+          <a:prstGeom prst="rect">
+            <a:avLst/>
+          </a:prstGeom>
+          <a:noFill/>
+        </p:spPr>
+        <p:txBody>
+          <a:bodyPr wrap="square">
+            <a:spAutoFit/>
+          </a:bodyPr>
+          <a:lstStyle/>
+          <a:p>
+            <a:pPr algn="l">
+              <a:lnSpc>
+                <a:spcPct val="100000"/>
+              </a:lnSpc>
+            </a:pPr>
+            <a:r>
+              <a:rPr sz="1900" b="1">
+                <a:solidFill>
+                  <a:srgbClr val="D55E00"/>
+                </a:solidFill>
+                <a:latin typeface="Segoe UI"/>
+              </a:rPr>
+              <a:t>Por que ainda não está aqui</a:t>
+            </a:r>
+          </a:p>
+        </p:txBody>
+      </p:sp>
+      <p:sp>
+        <p:nvSpPr>
+          <p:cNvPr id="10" name="TextBox 9"/>
+          <p:cNvSpPr txBox="1"/>
+          <p:nvPr/>
+        </p:nvSpPr>
+        <p:spPr>
+          <a:xfrm>
+            <a:off x="6629400" y="2057400"/>
+            <a:ext cx="4572000" cy="3657600"/>
+          </a:xfrm>
+          <a:prstGeom prst="rect">
+            <a:avLst/>
+          </a:prstGeom>
+          <a:noFill/>
+        </p:spPr>
+        <p:txBody>
+          <a:bodyPr wrap="square">
+            <a:spAutoFit/>
+          </a:bodyPr>
+          <a:lstStyle/>
+          <a:p>
+            <a:pPr>
+              <a:spcAft>
+                <a:spcPts val="1000"/>
+              </a:spcAft>
+            </a:pPr>
+            <a:r>
+              <a:rPr sz="1600">
+                <a:solidFill>
+                  <a:srgbClr val="52606D"/>
+                </a:solidFill>
+                <a:latin typeface="Segoe UI"/>
+              </a:rPr>
+              <a:t>Uma heurística aprendida NÃO é admissível por construção</a:t>
+            </a:r>
+          </a:p>
+          <a:p>
+            <a:pPr>
+              <a:spcAft>
+                <a:spcPts val="1000"/>
+              </a:spcAft>
+            </a:pPr>
+            <a:r>
+              <a:rPr sz="1600">
+                <a:solidFill>
+                  <a:srgbClr val="52606D"/>
+                </a:solidFill>
+                <a:latin typeface="Segoe UI"/>
+              </a:rPr>
+              <a:t>Regressão pode superestimar → A* perde a otimalidade em silêncio</a:t>
+            </a:r>
+          </a:p>
+          <a:p>
+            <a:pPr>
+              <a:spcAft>
+                <a:spcPts val="1000"/>
+              </a:spcAft>
+            </a:pPr>
+            <a:r>
+              <a:rPr sz="1600">
+                <a:solidFill>
+                  <a:srgbClr val="52606D"/>
+                </a:solidFill>
+                <a:latin typeface="Segoe UI"/>
+              </a:rPr>
+              <a:t>Saídas: usá-la só como desempate (preserva o ótimo)...</a:t>
+            </a:r>
+          </a:p>
+          <a:p>
+            <a:pPr>
+              <a:spcAft>
+                <a:spcPts val="1000"/>
+              </a:spcAft>
+            </a:pPr>
+            <a:r>
+              <a:rPr sz="1600">
+                <a:solidFill>
+                  <a:srgbClr val="52606D"/>
+                </a:solidFill>
+                <a:latin typeface="Segoe UI"/>
+              </a:rPr>
+              <a:t>...ou em busca limitadamente subótima, com fator de garantia</a:t>
+            </a:r>
+          </a:p>
+          <a:p>
+            <a:pPr>
+              <a:spcAft>
+                <a:spcPts val="1000"/>
+              </a:spcAft>
+            </a:pPr>
+            <a:r>
+              <a:rPr sz="1600">
+                <a:solidFill>
+                  <a:srgbClr val="52606D"/>
+                </a:solidFill>
+                <a:latin typeface="Segoe UI"/>
+              </a:rPr>
+              <a:t>Nossos testes de admissibilidade seriam o instrumento de medida</a:t>
+            </a:r>
+          </a:p>
+        </p:txBody>
+      </p:sp>
+    </p:spTree>
+  </p:cSld>
+  <p:clrMapOvr>
+    <a:masterClrMapping/>
+  </p:clrMapOvr>
+</p:sld>
+</file>
+
+<file path=ppt/slides/slide47.xml><?xml version="1.0" encoding="utf-8"?>
+<p:sld xmlns:a="http://schemas.openxmlformats.org/drawingml/2006/main" xmlns:p="http://schemas.openxmlformats.org/presentationml/2006/main" xmlns:r="http://schemas.openxmlformats.org/officeDocument/2006/relationships">
+  <p:cSld>
+    <p:spTree>
+      <p:nvGrpSpPr>
+        <p:cNvPr id="1" name=""/>
+        <p:cNvGrpSpPr/>
+        <p:nvPr/>
+      </p:nvGrpSpPr>
+      <p:grpSpPr/>
+      <p:sp>
+        <p:nvSpPr>
+          <p:cNvPr id="2" name="Rectangle 1"/>
+          <p:cNvSpPr/>
+          <p:nvPr/>
+        </p:nvSpPr>
+        <p:spPr>
+          <a:xfrm>
+            <a:off x="0" y="0"/>
+            <a:ext cx="12191695" cy="6858000"/>
+          </a:xfrm>
+          <a:prstGeom prst="rect">
+            <a:avLst/>
+          </a:prstGeom>
+          <a:solidFill>
             <a:srgbClr val="061219"/>
           </a:solidFill>
           <a:ln>
@@ -22389,7 +23091,7 @@
 </p:sld>
 </file>
 
-<file path=ppt/slides/slide47.xml><?xml version="1.0" encoding="utf-8"?>
+<file path=ppt/slides/slide48.xml><?xml version="1.0" encoding="utf-8"?>
 <p:sld xmlns:a="http://schemas.openxmlformats.org/drawingml/2006/main" xmlns:p="http://schemas.openxmlformats.org/presentationml/2006/main" xmlns:r="http://schemas.openxmlformats.org/officeDocument/2006/relationships">
   <p:cSld>
     <p:spTree>
@@ -22651,7 +23353,7 @@
 </p:sld>
 </file>
 
-<file path=ppt/slides/slide48.xml><?xml version="1.0" encoding="utf-8"?>
+<file path=ppt/slides/slide49.xml><?xml version="1.0" encoding="utf-8"?>
 <p:sld xmlns:a="http://schemas.openxmlformats.org/drawingml/2006/main" xmlns:p="http://schemas.openxmlformats.org/presentationml/2006/main" xmlns:r="http://schemas.openxmlformats.org/officeDocument/2006/relationships">
   <p:cSld>
     <p:spTree>
@@ -22985,254 +23687,6 @@
                 <a:latin typeface="Consolas"/>
               </a:rPr>
               <a:t>     NOC -&gt; LTE_CORE -&gt; LTE_ENB -&gt; RM_A5 -&gt; RECLOSER_7   92,22 ms</a:t>
-            </a:r>
-          </a:p>
-        </p:txBody>
-      </p:sp>
-    </p:spTree>
-  </p:cSld>
-  <p:clrMapOvr>
-    <a:masterClrMapping/>
-  </p:clrMapOvr>
-</p:sld>
-</file>
-
-<file path=ppt/slides/slide49.xml><?xml version="1.0" encoding="utf-8"?>
-<p:sld xmlns:a="http://schemas.openxmlformats.org/drawingml/2006/main" xmlns:p="http://schemas.openxmlformats.org/presentationml/2006/main" xmlns:r="http://schemas.openxmlformats.org/officeDocument/2006/relationships">
-  <p:cSld>
-    <p:spTree>
-      <p:nvGrpSpPr>
-        <p:cNvPr id="1" name=""/>
-        <p:cNvGrpSpPr/>
-        <p:nvPr/>
-      </p:nvGrpSpPr>
-      <p:grpSpPr/>
-      <p:sp>
-        <p:nvSpPr>
-          <p:cNvPr id="2" name="Rectangle 1"/>
-          <p:cNvSpPr/>
-          <p:nvPr/>
-        </p:nvSpPr>
-        <p:spPr>
-          <a:xfrm>
-            <a:off x="0" y="0"/>
-            <a:ext cx="12191695" cy="6858000"/>
-          </a:xfrm>
-          <a:prstGeom prst="rect">
-            <a:avLst/>
-          </a:prstGeom>
-          <a:solidFill>
-            <a:srgbClr val="FBFAF7"/>
-          </a:solidFill>
-          <a:ln>
-            <a:noFill/>
-          </a:ln>
-          <a:effectLst/>
-        </p:spPr>
-        <p:style>
-          <a:lnRef idx="1">
-            <a:schemeClr val="accent1"/>
-          </a:lnRef>
-          <a:fillRef idx="3">
-            <a:schemeClr val="accent1"/>
-          </a:fillRef>
-          <a:effectRef idx="2">
-            <a:schemeClr val="accent1"/>
-          </a:effectRef>
-          <a:fontRef idx="minor">
-            <a:schemeClr val="lt1"/>
-          </a:fontRef>
-        </p:style>
-        <p:txBody>
-          <a:bodyPr rtlCol="0" anchor="ctr"/>
-          <a:lstStyle/>
-          <a:p>
-            <a:pPr algn="ctr"/>
-          </a:p>
-        </p:txBody>
-      </p:sp>
-      <p:sp>
-        <p:nvSpPr>
-          <p:cNvPr id="3" name="Rectangle 2"/>
-          <p:cNvSpPr/>
-          <p:nvPr/>
-        </p:nvSpPr>
-        <p:spPr>
-          <a:xfrm>
-            <a:off x="0" y="0"/>
-            <a:ext cx="12191695" cy="146304"/>
-          </a:xfrm>
-          <a:prstGeom prst="rect">
-            <a:avLst/>
-          </a:prstGeom>
-          <a:solidFill>
-            <a:srgbClr val="D55E00"/>
-          </a:solidFill>
-          <a:ln>
-            <a:noFill/>
-          </a:ln>
-          <a:effectLst/>
-        </p:spPr>
-        <p:style>
-          <a:lnRef idx="1">
-            <a:schemeClr val="accent1"/>
-          </a:lnRef>
-          <a:fillRef idx="3">
-            <a:schemeClr val="accent1"/>
-          </a:fillRef>
-          <a:effectRef idx="2">
-            <a:schemeClr val="accent1"/>
-          </a:effectRef>
-          <a:fontRef idx="minor">
-            <a:schemeClr val="lt1"/>
-          </a:fontRef>
-        </p:style>
-        <p:txBody>
-          <a:bodyPr rtlCol="0" anchor="ctr"/>
-          <a:lstStyle/>
-          <a:p>
-            <a:pPr algn="ctr"/>
-          </a:p>
-        </p:txBody>
-      </p:sp>
-      <p:sp>
-        <p:nvSpPr>
-          <p:cNvPr id="4" name="TextBox 3"/>
-          <p:cNvSpPr txBox="1"/>
-          <p:nvPr/>
-        </p:nvSpPr>
-        <p:spPr>
-          <a:xfrm>
-            <a:off x="685800" y="457200"/>
-            <a:ext cx="10789920" cy="822960"/>
-          </a:xfrm>
-          <a:prstGeom prst="rect">
-            <a:avLst/>
-          </a:prstGeom>
-          <a:noFill/>
-        </p:spPr>
-        <p:txBody>
-          <a:bodyPr wrap="square">
-            <a:spAutoFit/>
-          </a:bodyPr>
-          <a:lstStyle/>
-          <a:p>
-            <a:pPr algn="l">
-              <a:lnSpc>
-                <a:spcPct val="100000"/>
-              </a:lnSpc>
-            </a:pPr>
-            <a:r>
-              <a:rPr sz="3200" b="1">
-                <a:solidFill>
-                  <a:srgbClr val="1F2933"/>
-                </a:solidFill>
-                <a:latin typeface="Segoe UI"/>
-              </a:rPr>
-              <a:t>Limites de validade</a:t>
-            </a:r>
-          </a:p>
-        </p:txBody>
-      </p:sp>
-      <p:sp>
-        <p:nvSpPr>
-          <p:cNvPr id="5" name="TextBox 4"/>
-          <p:cNvSpPr txBox="1"/>
-          <p:nvPr/>
-        </p:nvSpPr>
-        <p:spPr>
-          <a:xfrm>
-            <a:off x="685800" y="1371600"/>
-            <a:ext cx="10789920" cy="4937760"/>
-          </a:xfrm>
-          <a:prstGeom prst="rect">
-            <a:avLst/>
-          </a:prstGeom>
-          <a:noFill/>
-        </p:spPr>
-        <p:txBody>
-          <a:bodyPr wrap="square" anchor="ctr">
-            <a:spAutoFit/>
-          </a:bodyPr>
-          <a:lstStyle/>
-          <a:p>
-            <a:pPr>
-              <a:spcAft>
-                <a:spcPts val="1600"/>
-              </a:spcAft>
-            </a:pPr>
-            <a:r>
-              <a:rPr sz="2300" b="1">
-                <a:solidFill>
-                  <a:srgbClr val="1F2933"/>
-                </a:solidFill>
-                <a:latin typeface="Segoe UI"/>
-              </a:rPr>
-              <a:t>• A topologia é sintética — não representa nenhuma instalação real</a:t>
-            </a:r>
-          </a:p>
-          <a:p>
-            <a:pPr>
-              <a:spcAft>
-                <a:spcPts val="1600"/>
-              </a:spcAft>
-            </a:pPr>
-            <a:r>
-              <a:rPr sz="2300" b="1">
-                <a:solidFill>
-                  <a:srgbClr val="1F2933"/>
-                </a:solidFill>
-                <a:latin typeface="Segoe UI"/>
-              </a:rPr>
-              <a:t>• Os limiares são nominais e não calibrados</a:t>
-            </a:r>
-          </a:p>
-          <a:p>
-            <a:pPr>
-              <a:spcAft>
-                <a:spcPts val="1600"/>
-              </a:spcAft>
-            </a:pPr>
-            <a:r>
-              <a:rPr sz="2300" b="1">
-                <a:solidFill>
-                  <a:srgbClr val="1F2933"/>
-                </a:solidFill>
-                <a:latin typeface="Segoe UI"/>
-              </a:rPr>
-              <a:t>• Não existe conjunto de dados rotulado de falhas para este domínio</a:t>
-            </a:r>
-          </a:p>
-          <a:p>
-            <a:pPr>
-              <a:spcAft>
-                <a:spcPts val="1600"/>
-              </a:spcAft>
-            </a:pPr>
-            <a:r>
-              <a:rPr sz="2300" b="1">
-                <a:solidFill>
-                  <a:srgbClr val="1F2933"/>
-                </a:solidFill>
-                <a:latin typeface="Segoe UI"/>
-              </a:rPr>
-              <a:t>• O sistema recomenda, não atua — no planejador isso não é conselho: é precondição</a:t>
-            </a:r>
-          </a:p>
-          <a:p>
-            <a:pPr lvl="1">
-              <a:spcAft>
-                <a:spcPts val="1000"/>
-              </a:spcAft>
-            </a:pPr>
-            <a:r>
-              <a:rPr sz="1900" b="0">
-                <a:solidFill>
-                  <a:srgbClr val="52606D"/>
-                </a:solidFill>
-                <a:latin typeface="Segoe UI"/>
-              </a:rPr>
-              <a:t>Uma conclusão obtida aqui vale para ESTE MODELO, não para uma planta física</a:t>
             </a:r>
           </a:p>
         </p:txBody>
@@ -23763,6 +24217,254 @@
 </file>
 
 <file path=ppt/slides/slide50.xml><?xml version="1.0" encoding="utf-8"?>
+<p:sld xmlns:a="http://schemas.openxmlformats.org/drawingml/2006/main" xmlns:p="http://schemas.openxmlformats.org/presentationml/2006/main" xmlns:r="http://schemas.openxmlformats.org/officeDocument/2006/relationships">
+  <p:cSld>
+    <p:spTree>
+      <p:nvGrpSpPr>
+        <p:cNvPr id="1" name=""/>
+        <p:cNvGrpSpPr/>
+        <p:nvPr/>
+      </p:nvGrpSpPr>
+      <p:grpSpPr/>
+      <p:sp>
+        <p:nvSpPr>
+          <p:cNvPr id="2" name="Rectangle 1"/>
+          <p:cNvSpPr/>
+          <p:nvPr/>
+        </p:nvSpPr>
+        <p:spPr>
+          <a:xfrm>
+            <a:off x="0" y="0"/>
+            <a:ext cx="12191695" cy="6858000"/>
+          </a:xfrm>
+          <a:prstGeom prst="rect">
+            <a:avLst/>
+          </a:prstGeom>
+          <a:solidFill>
+            <a:srgbClr val="FBFAF7"/>
+          </a:solidFill>
+          <a:ln>
+            <a:noFill/>
+          </a:ln>
+          <a:effectLst/>
+        </p:spPr>
+        <p:style>
+          <a:lnRef idx="1">
+            <a:schemeClr val="accent1"/>
+          </a:lnRef>
+          <a:fillRef idx="3">
+            <a:schemeClr val="accent1"/>
+          </a:fillRef>
+          <a:effectRef idx="2">
+            <a:schemeClr val="accent1"/>
+          </a:effectRef>
+          <a:fontRef idx="minor">
+            <a:schemeClr val="lt1"/>
+          </a:fontRef>
+        </p:style>
+        <p:txBody>
+          <a:bodyPr rtlCol="0" anchor="ctr"/>
+          <a:lstStyle/>
+          <a:p>
+            <a:pPr algn="ctr"/>
+          </a:p>
+        </p:txBody>
+      </p:sp>
+      <p:sp>
+        <p:nvSpPr>
+          <p:cNvPr id="3" name="Rectangle 2"/>
+          <p:cNvSpPr/>
+          <p:nvPr/>
+        </p:nvSpPr>
+        <p:spPr>
+          <a:xfrm>
+            <a:off x="0" y="0"/>
+            <a:ext cx="12191695" cy="146304"/>
+          </a:xfrm>
+          <a:prstGeom prst="rect">
+            <a:avLst/>
+          </a:prstGeom>
+          <a:solidFill>
+            <a:srgbClr val="D55E00"/>
+          </a:solidFill>
+          <a:ln>
+            <a:noFill/>
+          </a:ln>
+          <a:effectLst/>
+        </p:spPr>
+        <p:style>
+          <a:lnRef idx="1">
+            <a:schemeClr val="accent1"/>
+          </a:lnRef>
+          <a:fillRef idx="3">
+            <a:schemeClr val="accent1"/>
+          </a:fillRef>
+          <a:effectRef idx="2">
+            <a:schemeClr val="accent1"/>
+          </a:effectRef>
+          <a:fontRef idx="minor">
+            <a:schemeClr val="lt1"/>
+          </a:fontRef>
+        </p:style>
+        <p:txBody>
+          <a:bodyPr rtlCol="0" anchor="ctr"/>
+          <a:lstStyle/>
+          <a:p>
+            <a:pPr algn="ctr"/>
+          </a:p>
+        </p:txBody>
+      </p:sp>
+      <p:sp>
+        <p:nvSpPr>
+          <p:cNvPr id="4" name="TextBox 3"/>
+          <p:cNvSpPr txBox="1"/>
+          <p:nvPr/>
+        </p:nvSpPr>
+        <p:spPr>
+          <a:xfrm>
+            <a:off x="685800" y="457200"/>
+            <a:ext cx="10789920" cy="822960"/>
+          </a:xfrm>
+          <a:prstGeom prst="rect">
+            <a:avLst/>
+          </a:prstGeom>
+          <a:noFill/>
+        </p:spPr>
+        <p:txBody>
+          <a:bodyPr wrap="square">
+            <a:spAutoFit/>
+          </a:bodyPr>
+          <a:lstStyle/>
+          <a:p>
+            <a:pPr algn="l">
+              <a:lnSpc>
+                <a:spcPct val="100000"/>
+              </a:lnSpc>
+            </a:pPr>
+            <a:r>
+              <a:rPr sz="3200" b="1">
+                <a:solidFill>
+                  <a:srgbClr val="1F2933"/>
+                </a:solidFill>
+                <a:latin typeface="Segoe UI"/>
+              </a:rPr>
+              <a:t>Limites de validade</a:t>
+            </a:r>
+          </a:p>
+        </p:txBody>
+      </p:sp>
+      <p:sp>
+        <p:nvSpPr>
+          <p:cNvPr id="5" name="TextBox 4"/>
+          <p:cNvSpPr txBox="1"/>
+          <p:nvPr/>
+        </p:nvSpPr>
+        <p:spPr>
+          <a:xfrm>
+            <a:off x="685800" y="1371600"/>
+            <a:ext cx="10789920" cy="4937760"/>
+          </a:xfrm>
+          <a:prstGeom prst="rect">
+            <a:avLst/>
+          </a:prstGeom>
+          <a:noFill/>
+        </p:spPr>
+        <p:txBody>
+          <a:bodyPr wrap="square" anchor="ctr">
+            <a:spAutoFit/>
+          </a:bodyPr>
+          <a:lstStyle/>
+          <a:p>
+            <a:pPr>
+              <a:spcAft>
+                <a:spcPts val="1600"/>
+              </a:spcAft>
+            </a:pPr>
+            <a:r>
+              <a:rPr sz="2300" b="1">
+                <a:solidFill>
+                  <a:srgbClr val="1F2933"/>
+                </a:solidFill>
+                <a:latin typeface="Segoe UI"/>
+              </a:rPr>
+              <a:t>• A topologia é sintética — não representa nenhuma instalação real</a:t>
+            </a:r>
+          </a:p>
+          <a:p>
+            <a:pPr>
+              <a:spcAft>
+                <a:spcPts val="1600"/>
+              </a:spcAft>
+            </a:pPr>
+            <a:r>
+              <a:rPr sz="2300" b="1">
+                <a:solidFill>
+                  <a:srgbClr val="1F2933"/>
+                </a:solidFill>
+                <a:latin typeface="Segoe UI"/>
+              </a:rPr>
+              <a:t>• Os limiares são nominais e não calibrados</a:t>
+            </a:r>
+          </a:p>
+          <a:p>
+            <a:pPr>
+              <a:spcAft>
+                <a:spcPts val="1600"/>
+              </a:spcAft>
+            </a:pPr>
+            <a:r>
+              <a:rPr sz="2300" b="1">
+                <a:solidFill>
+                  <a:srgbClr val="1F2933"/>
+                </a:solidFill>
+                <a:latin typeface="Segoe UI"/>
+              </a:rPr>
+              <a:t>• Não existe conjunto de dados rotulado de falhas para este domínio</a:t>
+            </a:r>
+          </a:p>
+          <a:p>
+            <a:pPr>
+              <a:spcAft>
+                <a:spcPts val="1600"/>
+              </a:spcAft>
+            </a:pPr>
+            <a:r>
+              <a:rPr sz="2300" b="1">
+                <a:solidFill>
+                  <a:srgbClr val="1F2933"/>
+                </a:solidFill>
+                <a:latin typeface="Segoe UI"/>
+              </a:rPr>
+              <a:t>• O sistema recomenda, não atua — no planejador isso não é conselho: é precondição</a:t>
+            </a:r>
+          </a:p>
+          <a:p>
+            <a:pPr lvl="1">
+              <a:spcAft>
+                <a:spcPts val="1000"/>
+              </a:spcAft>
+            </a:pPr>
+            <a:r>
+              <a:rPr sz="1900" b="0">
+                <a:solidFill>
+                  <a:srgbClr val="52606D"/>
+                </a:solidFill>
+                <a:latin typeface="Segoe UI"/>
+              </a:rPr>
+              <a:t>Uma conclusão obtida aqui vale para ESTE MODELO, não para uma planta física</a:t>
+            </a:r>
+          </a:p>
+        </p:txBody>
+      </p:sp>
+    </p:spTree>
+  </p:cSld>
+  <p:clrMapOvr>
+    <a:masterClrMapping/>
+  </p:clrMapOvr>
+</p:sld>
+</file>
+
+<file path=ppt/slides/slide51.xml><?xml version="1.0" encoding="utf-8"?>
 <p:sld xmlns:a="http://schemas.openxmlformats.org/drawingml/2006/main" xmlns:p="http://schemas.openxmlformats.org/presentationml/2006/main" xmlns:r="http://schemas.openxmlformats.org/officeDocument/2006/relationships">
   <p:cSld>
     <p:spTree>
@@ -24301,7 +25003,7 @@
 </p:sld>
 </file>
 
-<file path=ppt/slides/slide51.xml><?xml version="1.0" encoding="utf-8"?>
+<file path=ppt/slides/slide52.xml><?xml version="1.0" encoding="utf-8"?>
 <p:sld xmlns:a="http://schemas.openxmlformats.org/drawingml/2006/main" xmlns:p="http://schemas.openxmlformats.org/presentationml/2006/main" xmlns:r="http://schemas.openxmlformats.org/officeDocument/2006/relationships">
   <p:cSld>
     <p:spTree>

</xml_diff>

<commit_message>
Adopt the assessment protocol and correct the test count
docs/assessment-protocol.md becomes the place where grading is specified, linked
from the README. It is explicit that the weights are a self-assessment proposal
with no recorded instructor endorsement, and that the official grade remains the
instructor's - which is the property that makes it safe to publish.

The deck, script and README claimed 108 tests. The suite is now at 155, and a
stale count in material presented to an audience is a claim that fails on
inspection. The historical figure in the protocol's review record is left alone:
it correctly describes the commit that was reviewed, and rewriting it would
falsify the record rather than update it.
</commit_message>
<xml_diff>
--- a/docs/presentation/ai-for-smartgrids-apresentacao.pptx
+++ b/docs/presentation/ai-for-smartgrids-apresentacao.pptx
@@ -59,6 +59,8 @@
     <p:sldId id="307" r:id="rId59"/>
     <p:sldId id="308" r:id="rId60"/>
     <p:sldId id="309" r:id="rId61"/>
+    <p:sldId id="310" r:id="rId62"/>
+    <p:sldId id="311" r:id="rId63"/>
   </p:sldIdLst>
   <p:sldSz cx="12191695" cy="6858000" type="screen4x3"/>
   <p:notesSz cx="6858000" cy="9144000"/>
@@ -571,7 +573,7 @@
           <a:p/>
           <a:p>
             <a:r>
-              <a:t>Antes de começar, deixe rodando "python -m pytest": 108 testes verdes na tela</a:t>
+              <a:t>Antes de começar, deixe rodando "python -m pytest": 155 testes verdes na tela</a:t>
             </a:r>
           </a:p>
           <a:p>
@@ -1664,6 +1666,32 @@
               <a:t>função do trabalho 3. Ao final voltaremos a isso com um comando só.</a:t>
             </a:r>
           </a:p>
+          <a:p/>
+          <a:p>
+            <a:r>
+              <a:t>Em cerca de 20 segundos, explique a avaliação: requisitos, correção e evidência</a:t>
+            </a:r>
+          </a:p>
+          <a:p>
+            <a:r>
+              <a:t>reproduzível; pesos propostos 30/30/25/15, ainda sem endosso docente registrado.</a:t>
+            </a:r>
+          </a:p>
+          <a:p>
+            <a:r>
+              <a:t>O exemplo principal usa um diagnóstico selecionado por nó. Falhas simultâneas</a:t>
+            </a:r>
+          </a:p>
+          <a:p>
+            <a:r>
+              <a:t>são uma extensão avaliada separadamente. Consulte docs/assessment-protocol.md</a:t>
+            </a:r>
+          </a:p>
+          <a:p>
+            <a:r>
+              <a:t>e os dois slides de apêndice, ocultos para preservar os 90 minutos autorizados.</a:t>
+            </a:r>
+          </a:p>
         </p:txBody>
       </p:sp>
       <p:sp>
@@ -5508,7 +5536,7 @@
           <a:p/>
           <a:p>
             <a:r>
-              <a:t>O repositório é público, tem 108 testes verdes em integração contínua para</a:t>
+              <a:t>O repositório é público, tem 155 testes verdes em integração contínua para</a:t>
             </a:r>
           </a:p>
           <a:p>
@@ -5525,6 +5553,240 @@
           <a:p>
             <a:r>
               <a:t>Convide perguntas.</a:t>
+            </a:r>
+          </a:p>
+        </p:txBody>
+      </p:sp>
+      <p:sp>
+        <p:nvSpPr>
+          <p:cNvPr id="4" name="Slide Number Placeholder 3"/>
+          <p:cNvSpPr>
+            <a:spLocks noGrp="1"/>
+          </p:cNvSpPr>
+          <p:nvPr>
+            <p:ph type="sldNum" idx="5" sz="quarter"/>
+          </p:nvPr>
+        </p:nvSpPr>
+        <p:spPr/>
+      </p:sp>
+    </p:spTree>
+  </p:cSld>
+  <p:clrMapOvr>
+    <a:masterClrMapping/>
+  </p:clrMapOvr>
+</p:notes>
+</file>
+
+<file path=ppt/notesSlides/notesSlide55.xml><?xml version="1.0" encoding="utf-8"?>
+<p:notes xmlns:a="http://schemas.openxmlformats.org/drawingml/2006/main" xmlns:p="http://schemas.openxmlformats.org/presentationml/2006/main" xmlns:r="http://schemas.openxmlformats.org/officeDocument/2006/relationships">
+  <p:cSld>
+    <p:spTree>
+      <p:nvGrpSpPr>
+        <p:cNvPr id="1" name=""/>
+        <p:cNvGrpSpPr/>
+        <p:nvPr/>
+      </p:nvGrpSpPr>
+      <p:grpSpPr>
+        <a:xfrm>
+          <a:off x="0" y="0"/>
+          <a:ext cx="0" cy="0"/>
+          <a:chOff x="0" y="0"/>
+          <a:chExt cx="0" cy="0"/>
+        </a:xfrm>
+      </p:grpSpPr>
+      <p:sp>
+        <p:nvSpPr>
+          <p:cNvPr id="2" name="Slide Image Placeholder 1"/>
+          <p:cNvSpPr>
+            <a:spLocks noGrp="1"/>
+          </p:cNvSpPr>
+          <p:nvPr>
+            <p:ph type="sldImg" idx="2"/>
+          </p:nvPr>
+        </p:nvSpPr>
+        <p:spPr/>
+      </p:sp>
+      <p:sp>
+        <p:nvSpPr>
+          <p:cNvPr id="3" name="Notes Placeholder 2"/>
+          <p:cNvSpPr>
+            <a:spLocks noGrp="1"/>
+          </p:cNvSpPr>
+          <p:nvPr>
+            <p:ph type="body" idx="3" sz="quarter"/>
+          </p:nvPr>
+        </p:nvSpPr>
+        <p:spPr/>
+        <p:txBody>
+          <a:bodyPr/>
+          <a:lstStyle/>
+          <a:p>
+            <a:r>
+              <a:t>Material de consulta; não adiciona tempo à apresentação de 90 minutos.</a:t>
+            </a:r>
+          </a:p>
+          <a:p>
+            <a:r>
+              <a:t>Esta é uma proposta de autoavaliação, não uma rubrica oficial.</a:t>
+            </a:r>
+          </a:p>
+          <a:p/>
+          <a:p>
+            <a:r>
+              <a:t>Procedimento: relacionar requisitos à evidência; identificar o commit e qualquer</a:t>
+            </a:r>
+          </a:p>
+          <a:p>
+            <a:r>
+              <a:t>diff local; executar as verificações; justificar a pontuação por critério;</a:t>
+            </a:r>
+          </a:p>
+          <a:p>
+            <a:r>
+              <a:t>registrar eventual manifestação explícita do professor. Sem resposta, manter o</a:t>
+            </a:r>
+          </a:p>
+          <a:p>
+            <a:r>
+              <a:t>status de proposta. O endosso dos critérios não endossa automaticamente a nota.</a:t>
+            </a:r>
+          </a:p>
+          <a:p/>
+          <a:p>
+            <a:r>
+              <a:t>Detalhamento, matriz de evidências e texto sugerido para solicitar apreciação:</a:t>
+            </a:r>
+          </a:p>
+          <a:p>
+            <a:r>
+              <a:t>docs/assessment-protocol.md. A revisão preliminar de 85/100 pertence ao commit</a:t>
+            </a:r>
+          </a:p>
+          <a:p>
+            <a:r>
+              <a:t>8d47ced, anterior a esta rubrica detalhada, e não é nota docente. Defesa oral</a:t>
+            </a:r>
+          </a:p>
+          <a:p>
+            <a:r>
+              <a:t>ainda não observada permanece pendente.</a:t>
+            </a:r>
+          </a:p>
+        </p:txBody>
+      </p:sp>
+      <p:sp>
+        <p:nvSpPr>
+          <p:cNvPr id="4" name="Slide Number Placeholder 3"/>
+          <p:cNvSpPr>
+            <a:spLocks noGrp="1"/>
+          </p:cNvSpPr>
+          <p:nvPr>
+            <p:ph type="sldNum" idx="5" sz="quarter"/>
+          </p:nvPr>
+        </p:nvSpPr>
+        <p:spPr/>
+      </p:sp>
+    </p:spTree>
+  </p:cSld>
+  <p:clrMapOvr>
+    <a:masterClrMapping/>
+  </p:clrMapOvr>
+</p:notes>
+</file>
+
+<file path=ppt/notesSlides/notesSlide56.xml><?xml version="1.0" encoding="utf-8"?>
+<p:notes xmlns:a="http://schemas.openxmlformats.org/drawingml/2006/main" xmlns:p="http://schemas.openxmlformats.org/presentationml/2006/main" xmlns:r="http://schemas.openxmlformats.org/officeDocument/2006/relationships">
+  <p:cSld>
+    <p:spTree>
+      <p:nvGrpSpPr>
+        <p:cNvPr id="1" name=""/>
+        <p:cNvGrpSpPr/>
+        <p:nvPr/>
+      </p:nvGrpSpPr>
+      <p:grpSpPr>
+        <a:xfrm>
+          <a:off x="0" y="0"/>
+          <a:ext cx="0" cy="0"/>
+          <a:chOff x="0" y="0"/>
+          <a:chExt cx="0" cy="0"/>
+        </a:xfrm>
+      </p:grpSpPr>
+      <p:sp>
+        <p:nvSpPr>
+          <p:cNvPr id="2" name="Slide Image Placeholder 1"/>
+          <p:cNvSpPr>
+            <a:spLocks noGrp="1"/>
+          </p:cNvSpPr>
+          <p:nvPr>
+            <p:ph type="sldImg" idx="2"/>
+          </p:nvPr>
+        </p:nvSpPr>
+        <p:spPr/>
+      </p:sp>
+      <p:sp>
+        <p:nvSpPr>
+          <p:cNvPr id="3" name="Notes Placeholder 2"/>
+          <p:cNvSpPr>
+            <a:spLocks noGrp="1"/>
+          </p:cNvSpPr>
+          <p:nvPr>
+            <p:ph type="body" idx="3" sz="quarter"/>
+          </p:nvPr>
+        </p:nvSpPr>
+        <p:spPr/>
+        <p:txBody>
+          <a:bodyPr/>
+          <a:lstStyle/>
+          <a:p>
+            <a:r>
+              <a:t>A simplificação é uma escolha didática: permite concentrar a defesa em</a:t>
+            </a:r>
+          </a:p>
+          <a:p>
+            <a:r>
+              <a:t>regras, estados, precondições e busca. Não descreve todas as falhas de uma rede.</a:t>
+            </a:r>
+          </a:p>
+          <a:p/>
+          <a:p>
+            <a:r>
+              <a:t>Para a extensão, demonstrar interferência com falha de alimentação; preservar os</a:t>
+            </a:r>
+          </a:p>
+          <a:p>
+            <a:r>
+              <a:t>casos de falha única e saudável; rejeitar falhas desconhecidas; impedir fechamento</a:t>
+            </a:r>
+          </a:p>
+          <a:p>
+            <a:r>
+              <a:t>quando uma falha não puder ser resolvida. Considerar interações e restrições das</a:t>
+            </a:r>
+          </a:p>
+          <a:p>
+            <a:r>
+              <a:t>ações. Planejar várias falhas fornecidas não demonstra diagnóstico multicausal.</a:t>
+            </a:r>
+          </a:p>
+          <a:p/>
+          <a:p>
+            <a:r>
+              <a:t>Autorização e verificação são efeitos assumidos no modelo determinístico;</a:t>
+            </a:r>
+          </a:p>
+          <a:p>
+            <a:r>
+              <a:t>o planejador não obtém aprovação humana nem mede recuperação física.</a:t>
+            </a:r>
+          </a:p>
+          <a:p>
+            <a:r>
+              <a:t>Os 90 minutos foram confirmados pelo autor como autorizados pelo professor.</a:t>
+            </a:r>
+          </a:p>
+          <a:p>
+            <a:r>
+              <a:t>Este apêndice é opcional; não amplia a duração.</a:t>
             </a:r>
           </a:p>
         </p:txBody>
@@ -25245,7 +25507,7 @@
                 </a:solidFill>
                 <a:latin typeface="Segoe UI"/>
               </a:rPr>
-              <a:t>Transversal: 108 testes; admissibilidade verificada em todos os pares</a:t>
+              <a:t>Transversal: 155 testes; admissibilidade verificada em todos os pares</a:t>
             </a:r>
           </a:p>
         </p:txBody>
@@ -26824,7 +27086,806 @@
                 </a:solidFill>
                 <a:latin typeface="Segoe UI"/>
               </a:rPr>
-              <a:t>github.com/fsd-dantas/ai-for-smartgrids   ·   108 testes   ·   wiki com a teoria da disciplina</a:t>
+              <a:t>github.com/fsd-dantas/ai-for-smartgrids   ·   155 testes   ·   wiki com a teoria da disciplina</a:t>
+            </a:r>
+          </a:p>
+        </p:txBody>
+      </p:sp>
+    </p:spTree>
+  </p:cSld>
+  <p:clrMapOvr>
+    <a:masterClrMapping/>
+  </p:clrMapOvr>
+</p:sld>
+</file>
+
+<file path=ppt/slides/slide55.xml><?xml version="1.0" encoding="utf-8"?>
+<p:sld xmlns:a="http://schemas.openxmlformats.org/drawingml/2006/main" xmlns:p="http://schemas.openxmlformats.org/presentationml/2006/main" xmlns:r="http://schemas.openxmlformats.org/officeDocument/2006/relationships" show="0">
+  <p:cSld>
+    <p:spTree>
+      <p:nvGrpSpPr>
+        <p:cNvPr id="1" name=""/>
+        <p:cNvGrpSpPr/>
+        <p:nvPr/>
+      </p:nvGrpSpPr>
+      <p:grpSpPr/>
+      <p:sp>
+        <p:nvSpPr>
+          <p:cNvPr id="2" name="Rectangle 1"/>
+          <p:cNvSpPr/>
+          <p:nvPr/>
+        </p:nvSpPr>
+        <p:spPr>
+          <a:xfrm>
+            <a:off x="0" y="0"/>
+            <a:ext cx="12191695" cy="6858000"/>
+          </a:xfrm>
+          <a:prstGeom prst="rect">
+            <a:avLst/>
+          </a:prstGeom>
+          <a:solidFill>
+            <a:srgbClr val="FBFAF7"/>
+          </a:solidFill>
+          <a:ln>
+            <a:noFill/>
+          </a:ln>
+          <a:effectLst/>
+        </p:spPr>
+        <p:style>
+          <a:lnRef idx="1">
+            <a:schemeClr val="accent1"/>
+          </a:lnRef>
+          <a:fillRef idx="3">
+            <a:schemeClr val="accent1"/>
+          </a:fillRef>
+          <a:effectRef idx="2">
+            <a:schemeClr val="accent1"/>
+          </a:effectRef>
+          <a:fontRef idx="minor">
+            <a:schemeClr val="lt1"/>
+          </a:fontRef>
+        </p:style>
+        <p:txBody>
+          <a:bodyPr rtlCol="0" anchor="ctr"/>
+          <a:lstStyle/>
+          <a:p>
+            <a:pPr algn="ctr"/>
+          </a:p>
+        </p:txBody>
+      </p:sp>
+      <p:sp>
+        <p:nvSpPr>
+          <p:cNvPr id="3" name="Rectangle 2"/>
+          <p:cNvSpPr/>
+          <p:nvPr/>
+        </p:nvSpPr>
+        <p:spPr>
+          <a:xfrm>
+            <a:off x="0" y="0"/>
+            <a:ext cx="12191695" cy="146304"/>
+          </a:xfrm>
+          <a:prstGeom prst="rect">
+            <a:avLst/>
+          </a:prstGeom>
+          <a:solidFill>
+            <a:srgbClr val="0072B2"/>
+          </a:solidFill>
+          <a:ln>
+            <a:noFill/>
+          </a:ln>
+          <a:effectLst/>
+        </p:spPr>
+        <p:style>
+          <a:lnRef idx="1">
+            <a:schemeClr val="accent1"/>
+          </a:lnRef>
+          <a:fillRef idx="3">
+            <a:schemeClr val="accent1"/>
+          </a:fillRef>
+          <a:effectRef idx="2">
+            <a:schemeClr val="accent1"/>
+          </a:effectRef>
+          <a:fontRef idx="minor">
+            <a:schemeClr val="lt1"/>
+          </a:fontRef>
+        </p:style>
+        <p:txBody>
+          <a:bodyPr rtlCol="0" anchor="ctr"/>
+          <a:lstStyle/>
+          <a:p>
+            <a:pPr algn="ctr"/>
+          </a:p>
+        </p:txBody>
+      </p:sp>
+      <p:sp>
+        <p:nvSpPr>
+          <p:cNvPr id="4" name="TextBox 3"/>
+          <p:cNvSpPr txBox="1"/>
+          <p:nvPr/>
+        </p:nvSpPr>
+        <p:spPr>
+          <a:xfrm>
+            <a:off x="685800" y="384048"/>
+            <a:ext cx="10789920" cy="731520"/>
+          </a:xfrm>
+          <a:prstGeom prst="rect">
+            <a:avLst/>
+          </a:prstGeom>
+          <a:noFill/>
+        </p:spPr>
+        <p:txBody>
+          <a:bodyPr wrap="square">
+            <a:spAutoFit/>
+          </a:bodyPr>
+          <a:lstStyle/>
+          <a:p>
+            <a:pPr algn="l">
+              <a:lnSpc>
+                <a:spcPct val="100000"/>
+              </a:lnSpc>
+            </a:pPr>
+            <a:r>
+              <a:rPr sz="3000" b="1">
+                <a:solidFill>
+                  <a:srgbClr val="1F2933"/>
+                </a:solidFill>
+                <a:latin typeface="Segoe UI"/>
+              </a:rPr>
+              <a:t>Apêndice — proposta de avaliação</a:t>
+            </a:r>
+          </a:p>
+        </p:txBody>
+      </p:sp>
+      <p:sp>
+        <p:nvSpPr>
+          <p:cNvPr id="5" name="TextBox 4"/>
+          <p:cNvSpPr txBox="1"/>
+          <p:nvPr/>
+        </p:nvSpPr>
+        <p:spPr>
+          <a:xfrm>
+            <a:off x="685800" y="1188720"/>
+            <a:ext cx="10789920" cy="457200"/>
+          </a:xfrm>
+          <a:prstGeom prst="rect">
+            <a:avLst/>
+          </a:prstGeom>
+          <a:noFill/>
+        </p:spPr>
+        <p:txBody>
+          <a:bodyPr wrap="square">
+            <a:spAutoFit/>
+          </a:bodyPr>
+          <a:lstStyle/>
+          <a:p>
+            <a:pPr algn="l">
+              <a:lnSpc>
+                <a:spcPct val="100000"/>
+              </a:lnSpc>
+            </a:pPr>
+            <a:r>
+              <a:rPr sz="1500" b="0">
+                <a:solidFill>
+                  <a:srgbClr val="52606D"/>
+                </a:solidFill>
+                <a:latin typeface="Segoe UI"/>
+              </a:rPr>
+              <a:t>Autoavaliação proposta • sem endosso docente registrado</a:t>
+            </a:r>
+          </a:p>
+        </p:txBody>
+      </p:sp>
+      <p:graphicFrame>
+        <p:nvGraphicFramePr>
+          <p:cNvPr id="6" name="Table 5"/>
+          <p:cNvGraphicFramePr>
+            <a:graphicFrameLocks noGrp="1"/>
+          </p:cNvGraphicFramePr>
+          <p:nvPr/>
+        </p:nvGraphicFramePr>
+        <p:xfrm>
+          <a:off x="685800" y="1737360"/>
+          <a:ext cx="10789919" cy="2103120"/>
+        </p:xfrm>
+        <a:graphic>
+          <a:graphicData uri="http://schemas.openxmlformats.org/drawingml/2006/table">
+            <a:tbl>
+              <a:tblPr firstRow="1" bandRow="1">
+                <a:tableStyleId>{5C22544A-7EE6-4342-B048-85BDC9FD1C3A}</a:tableStyleId>
+              </a:tblPr>
+              <a:tblGrid>
+                <a:gridCol w="2926080"/>
+                <a:gridCol w="914400"/>
+                <a:gridCol w="6949439"/>
+              </a:tblGrid>
+              <a:tr h="420624">
+                <a:tc>
+                  <a:txBody>
+                    <a:bodyPr/>
+                    <a:lstStyle/>
+                    <a:p>
+                      <a:r>
+                        <a:rPr sz="1500" b="1">
+                          <a:solidFill>
+                            <a:srgbClr val="FFFFFF"/>
+                          </a:solidFill>
+                          <a:latin typeface="Segoe UI"/>
+                        </a:rPr>
+                        <a:t>Área</a:t>
+                      </a:r>
+                    </a:p>
+                  </a:txBody>
+                  <a:tcPr anchor="ctr">
+                    <a:solidFill>
+                      <a:srgbClr val="0072B2"/>
+                    </a:solidFill>
+                  </a:tcPr>
+                </a:tc>
+                <a:tc>
+                  <a:txBody>
+                    <a:bodyPr/>
+                    <a:lstStyle/>
+                    <a:p>
+                      <a:r>
+                        <a:rPr sz="1500" b="1">
+                          <a:solidFill>
+                            <a:srgbClr val="FFFFFF"/>
+                          </a:solidFill>
+                          <a:latin typeface="Segoe UI"/>
+                        </a:rPr>
+                        <a:t>Pontos</a:t>
+                      </a:r>
+                    </a:p>
+                  </a:txBody>
+                  <a:tcPr anchor="ctr">
+                    <a:solidFill>
+                      <a:srgbClr val="0072B2"/>
+                    </a:solidFill>
+                  </a:tcPr>
+                </a:tc>
+                <a:tc>
+                  <a:txBody>
+                    <a:bodyPr/>
+                    <a:lstStyle/>
+                    <a:p>
+                      <a:r>
+                        <a:rPr sz="1500" b="1">
+                          <a:solidFill>
+                            <a:srgbClr val="FFFFFF"/>
+                          </a:solidFill>
+                          <a:latin typeface="Segoe UI"/>
+                        </a:rPr>
+                        <a:t>Evidência principal</a:t>
+                      </a:r>
+                    </a:p>
+                  </a:txBody>
+                  <a:tcPr anchor="ctr">
+                    <a:solidFill>
+                      <a:srgbClr val="0072B2"/>
+                    </a:solidFill>
+                  </a:tcPr>
+                </a:tc>
+              </a:tr>
+              <a:tr h="420624">
+                <a:tc>
+                  <a:txBody>
+                    <a:bodyPr/>
+                    <a:lstStyle/>
+                    <a:p>
+                      <a:r>
+                        <a:rPr sz="1400" b="0">
+                          <a:solidFill>
+                            <a:srgbClr val="52606D"/>
+                          </a:solidFill>
+                          <a:latin typeface="Segoe UI"/>
+                        </a:rPr>
+                        <a:t>Sistema especialista</a:t>
+                      </a:r>
+                    </a:p>
+                  </a:txBody>
+                  <a:tcPr anchor="ctr">
+                    <a:solidFill>
+                      <a:srgbClr val="FFFFFF"/>
+                    </a:solidFill>
+                  </a:tcPr>
+                </a:tc>
+                <a:tc>
+                  <a:txBody>
+                    <a:bodyPr/>
+                    <a:lstStyle/>
+                    <a:p>
+                      <a:r>
+                        <a:rPr sz="1400" b="0">
+                          <a:solidFill>
+                            <a:srgbClr val="52606D"/>
+                          </a:solidFill>
+                          <a:latin typeface="Segoe UI"/>
+                        </a:rPr>
+                        <a:t>30</a:t>
+                      </a:r>
+                    </a:p>
+                  </a:txBody>
+                  <a:tcPr anchor="ctr">
+                    <a:solidFill>
+                      <a:srgbClr val="FFFFFF"/>
+                    </a:solidFill>
+                  </a:tcPr>
+                </a:tc>
+                <a:tc>
+                  <a:txBody>
+                    <a:bodyPr/>
+                    <a:lstStyle/>
+                    <a:p>
+                      <a:r>
+                        <a:rPr sz="1400" b="0">
+                          <a:solidFill>
+                            <a:srgbClr val="52606D"/>
+                          </a:solidFill>
+                          <a:latin typeface="Segoe UI"/>
+                        </a:rPr>
+                        <a:t>Regras, encadeamento, CF e explicação</a:t>
+                      </a:r>
+                    </a:p>
+                  </a:txBody>
+                  <a:tcPr anchor="ctr">
+                    <a:solidFill>
+                      <a:srgbClr val="FFFFFF"/>
+                    </a:solidFill>
+                  </a:tcPr>
+                </a:tc>
+              </a:tr>
+              <a:tr h="420624">
+                <a:tc>
+                  <a:txBody>
+                    <a:bodyPr/>
+                    <a:lstStyle/>
+                    <a:p>
+                      <a:r>
+                        <a:rPr sz="1400" b="0">
+                          <a:solidFill>
+                            <a:srgbClr val="52606D"/>
+                          </a:solidFill>
+                          <a:latin typeface="Segoe UI"/>
+                        </a:rPr>
+                        <a:t>Planejamento</a:t>
+                      </a:r>
+                    </a:p>
+                  </a:txBody>
+                  <a:tcPr anchor="ctr">
+                    <a:solidFill>
+                      <a:srgbClr val="F4F2EE"/>
+                    </a:solidFill>
+                  </a:tcPr>
+                </a:tc>
+                <a:tc>
+                  <a:txBody>
+                    <a:bodyPr/>
+                    <a:lstStyle/>
+                    <a:p>
+                      <a:r>
+                        <a:rPr sz="1400" b="0">
+                          <a:solidFill>
+                            <a:srgbClr val="52606D"/>
+                          </a:solidFill>
+                          <a:latin typeface="Segoe UI"/>
+                        </a:rPr>
+                        <a:t>30</a:t>
+                      </a:r>
+                    </a:p>
+                  </a:txBody>
+                  <a:tcPr anchor="ctr">
+                    <a:solidFill>
+                      <a:srgbClr val="F4F2EE"/>
+                    </a:solidFill>
+                  </a:tcPr>
+                </a:tc>
+                <a:tc>
+                  <a:txBody>
+                    <a:bodyPr/>
+                    <a:lstStyle/>
+                    <a:p>
+                      <a:r>
+                        <a:rPr sz="1400" b="0">
+                          <a:solidFill>
+                            <a:srgbClr val="52606D"/>
+                          </a:solidFill>
+                          <a:latin typeface="Segoe UI"/>
+                        </a:rPr>
+                        <a:t>Modelo, plano executável e integração</a:t>
+                      </a:r>
+                    </a:p>
+                  </a:txBody>
+                  <a:tcPr anchor="ctr">
+                    <a:solidFill>
+                      <a:srgbClr val="F4F2EE"/>
+                    </a:solidFill>
+                  </a:tcPr>
+                </a:tc>
+              </a:tr>
+              <a:tr h="420624">
+                <a:tc>
+                  <a:txBody>
+                    <a:bodyPr/>
+                    <a:lstStyle/>
+                    <a:p>
+                      <a:r>
+                        <a:rPr sz="1400" b="0">
+                          <a:solidFill>
+                            <a:srgbClr val="52606D"/>
+                          </a:solidFill>
+                          <a:latin typeface="Segoe UI"/>
+                        </a:rPr>
+                        <a:t>Busca A*</a:t>
+                      </a:r>
+                    </a:p>
+                  </a:txBody>
+                  <a:tcPr anchor="ctr">
+                    <a:solidFill>
+                      <a:srgbClr val="FFFFFF"/>
+                    </a:solidFill>
+                  </a:tcPr>
+                </a:tc>
+                <a:tc>
+                  <a:txBody>
+                    <a:bodyPr/>
+                    <a:lstStyle/>
+                    <a:p>
+                      <a:r>
+                        <a:rPr sz="1400" b="0">
+                          <a:solidFill>
+                            <a:srgbClr val="52606D"/>
+                          </a:solidFill>
+                          <a:latin typeface="Segoe UI"/>
+                        </a:rPr>
+                        <a:t>25</a:t>
+                      </a:r>
+                    </a:p>
+                  </a:txBody>
+                  <a:tcPr anchor="ctr">
+                    <a:solidFill>
+                      <a:srgbClr val="FFFFFF"/>
+                    </a:solidFill>
+                  </a:tcPr>
+                </a:tc>
+                <a:tc>
+                  <a:txBody>
+                    <a:bodyPr/>
+                    <a:lstStyle/>
+                    <a:p>
+                      <a:r>
+                        <a:rPr sz="1400" b="0">
+                          <a:solidFill>
+                            <a:srgbClr val="52606D"/>
+                          </a:solidFill>
+                          <a:latin typeface="Segoe UI"/>
+                        </a:rPr>
+                        <a:t>Caminho, custo, heurística e comparação</a:t>
+                      </a:r>
+                    </a:p>
+                  </a:txBody>
+                  <a:tcPr anchor="ctr">
+                    <a:solidFill>
+                      <a:srgbClr val="FFFFFF"/>
+                    </a:solidFill>
+                  </a:tcPr>
+                </a:tc>
+              </a:tr>
+              <a:tr h="420624">
+                <a:tc>
+                  <a:txBody>
+                    <a:bodyPr/>
+                    <a:lstStyle/>
+                    <a:p>
+                      <a:r>
+                        <a:rPr sz="1400" b="0">
+                          <a:solidFill>
+                            <a:srgbClr val="52606D"/>
+                          </a:solidFill>
+                          <a:latin typeface="Segoe UI"/>
+                        </a:rPr>
+                        <a:t>Documentação e defesa</a:t>
+                      </a:r>
+                    </a:p>
+                  </a:txBody>
+                  <a:tcPr anchor="ctr">
+                    <a:solidFill>
+                      <a:srgbClr val="F4F2EE"/>
+                    </a:solidFill>
+                  </a:tcPr>
+                </a:tc>
+                <a:tc>
+                  <a:txBody>
+                    <a:bodyPr/>
+                    <a:lstStyle/>
+                    <a:p>
+                      <a:r>
+                        <a:rPr sz="1400" b="0">
+                          <a:solidFill>
+                            <a:srgbClr val="52606D"/>
+                          </a:solidFill>
+                          <a:latin typeface="Segoe UI"/>
+                        </a:rPr>
+                        <a:t>15</a:t>
+                      </a:r>
+                    </a:p>
+                  </a:txBody>
+                  <a:tcPr anchor="ctr">
+                    <a:solidFill>
+                      <a:srgbClr val="F4F2EE"/>
+                    </a:solidFill>
+                  </a:tcPr>
+                </a:tc>
+                <a:tc>
+                  <a:txBody>
+                    <a:bodyPr/>
+                    <a:lstStyle/>
+                    <a:p>
+                      <a:r>
+                        <a:rPr sz="1400" b="0">
+                          <a:solidFill>
+                            <a:srgbClr val="52606D"/>
+                          </a:solidFill>
+                          <a:latin typeface="Segoe UI"/>
+                        </a:rPr>
+                        <a:t>Reprodução, clareza e limites</a:t>
+                      </a:r>
+                    </a:p>
+                  </a:txBody>
+                  <a:tcPr anchor="ctr">
+                    <a:solidFill>
+                      <a:srgbClr val="F4F2EE"/>
+                    </a:solidFill>
+                  </a:tcPr>
+                </a:tc>
+              </a:tr>
+            </a:tbl>
+          </a:graphicData>
+        </a:graphic>
+      </p:graphicFrame>
+    </p:spTree>
+  </p:cSld>
+  <p:clrMapOvr>
+    <a:masterClrMapping/>
+  </p:clrMapOvr>
+</p:sld>
+</file>
+
+<file path=ppt/slides/slide56.xml><?xml version="1.0" encoding="utf-8"?>
+<p:sld xmlns:a="http://schemas.openxmlformats.org/drawingml/2006/main" xmlns:p="http://schemas.openxmlformats.org/presentationml/2006/main" xmlns:r="http://schemas.openxmlformats.org/officeDocument/2006/relationships" show="0">
+  <p:cSld>
+    <p:spTree>
+      <p:nvGrpSpPr>
+        <p:cNvPr id="1" name=""/>
+        <p:cNvGrpSpPr/>
+        <p:nvPr/>
+      </p:nvGrpSpPr>
+      <p:grpSpPr/>
+      <p:sp>
+        <p:nvSpPr>
+          <p:cNvPr id="2" name="Rectangle 1"/>
+          <p:cNvSpPr/>
+          <p:nvPr/>
+        </p:nvSpPr>
+        <p:spPr>
+          <a:xfrm>
+            <a:off x="0" y="0"/>
+            <a:ext cx="12191695" cy="6858000"/>
+          </a:xfrm>
+          <a:prstGeom prst="rect">
+            <a:avLst/>
+          </a:prstGeom>
+          <a:solidFill>
+            <a:srgbClr val="FBFAF7"/>
+          </a:solidFill>
+          <a:ln>
+            <a:noFill/>
+          </a:ln>
+          <a:effectLst/>
+        </p:spPr>
+        <p:style>
+          <a:lnRef idx="1">
+            <a:schemeClr val="accent1"/>
+          </a:lnRef>
+          <a:fillRef idx="3">
+            <a:schemeClr val="accent1"/>
+          </a:fillRef>
+          <a:effectRef idx="2">
+            <a:schemeClr val="accent1"/>
+          </a:effectRef>
+          <a:fontRef idx="minor">
+            <a:schemeClr val="lt1"/>
+          </a:fontRef>
+        </p:style>
+        <p:txBody>
+          <a:bodyPr rtlCol="0" anchor="ctr"/>
+          <a:lstStyle/>
+          <a:p>
+            <a:pPr algn="ctr"/>
+          </a:p>
+        </p:txBody>
+      </p:sp>
+      <p:sp>
+        <p:nvSpPr>
+          <p:cNvPr id="3" name="Rectangle 2"/>
+          <p:cNvSpPr/>
+          <p:nvPr/>
+        </p:nvSpPr>
+        <p:spPr>
+          <a:xfrm>
+            <a:off x="0" y="0"/>
+            <a:ext cx="12191695" cy="146304"/>
+          </a:xfrm>
+          <a:prstGeom prst="rect">
+            <a:avLst/>
+          </a:prstGeom>
+          <a:solidFill>
+            <a:srgbClr val="009E73"/>
+          </a:solidFill>
+          <a:ln>
+            <a:noFill/>
+          </a:ln>
+          <a:effectLst/>
+        </p:spPr>
+        <p:style>
+          <a:lnRef idx="1">
+            <a:schemeClr val="accent1"/>
+          </a:lnRef>
+          <a:fillRef idx="3">
+            <a:schemeClr val="accent1"/>
+          </a:fillRef>
+          <a:effectRef idx="2">
+            <a:schemeClr val="accent1"/>
+          </a:effectRef>
+          <a:fontRef idx="minor">
+            <a:schemeClr val="lt1"/>
+          </a:fontRef>
+        </p:style>
+        <p:txBody>
+          <a:bodyPr rtlCol="0" anchor="ctr"/>
+          <a:lstStyle/>
+          <a:p>
+            <a:pPr algn="ctr"/>
+          </a:p>
+        </p:txBody>
+      </p:sp>
+      <p:sp>
+        <p:nvSpPr>
+          <p:cNvPr id="4" name="TextBox 3"/>
+          <p:cNvSpPr txBox="1"/>
+          <p:nvPr/>
+        </p:nvSpPr>
+        <p:spPr>
+          <a:xfrm>
+            <a:off x="685800" y="457200"/>
+            <a:ext cx="10789920" cy="822960"/>
+          </a:xfrm>
+          <a:prstGeom prst="rect">
+            <a:avLst/>
+          </a:prstGeom>
+          <a:noFill/>
+        </p:spPr>
+        <p:txBody>
+          <a:bodyPr wrap="square">
+            <a:spAutoFit/>
+          </a:bodyPr>
+          <a:lstStyle/>
+          <a:p>
+            <a:pPr algn="l">
+              <a:lnSpc>
+                <a:spcPct val="100000"/>
+              </a:lnSpc>
+            </a:pPr>
+            <a:r>
+              <a:rPr sz="3200" b="1">
+                <a:solidFill>
+                  <a:srgbClr val="1F2933"/>
+                </a:solidFill>
+                <a:latin typeface="Segoe UI"/>
+              </a:rPr>
+              <a:t>Apêndice — escopo das falhas</a:t>
+            </a:r>
+          </a:p>
+        </p:txBody>
+      </p:sp>
+      <p:sp>
+        <p:nvSpPr>
+          <p:cNvPr id="5" name="TextBox 4"/>
+          <p:cNvSpPr txBox="1"/>
+          <p:nvPr/>
+        </p:nvSpPr>
+        <p:spPr>
+          <a:xfrm>
+            <a:off x="685800" y="1371600"/>
+            <a:ext cx="10789920" cy="4937760"/>
+          </a:xfrm>
+          <a:prstGeom prst="rect">
+            <a:avLst/>
+          </a:prstGeom>
+          <a:noFill/>
+        </p:spPr>
+        <p:txBody>
+          <a:bodyPr wrap="square" anchor="ctr">
+            <a:spAutoFit/>
+          </a:bodyPr>
+          <a:lstStyle/>
+          <a:p>
+            <a:pPr>
+              <a:spcAft>
+                <a:spcPts val="1600"/>
+              </a:spcAft>
+            </a:pPr>
+            <a:r>
+              <a:rPr sz="2300" b="1">
+                <a:solidFill>
+                  <a:srgbClr val="1F2933"/>
+                </a:solidFill>
+                <a:latin typeface="Segoe UI"/>
+              </a:rPr>
+              <a:t>• Demonstração principal: um diagnóstico selecionado por nó</a:t>
+            </a:r>
+          </a:p>
+          <a:p>
+            <a:pPr>
+              <a:spcAft>
+                <a:spcPts val="1600"/>
+              </a:spcAft>
+            </a:pPr>
+            <a:r>
+              <a:rPr sz="2300" b="1">
+                <a:solidFill>
+                  <a:srgbClr val="1F2933"/>
+                </a:solidFill>
+                <a:latin typeface="Segoe UI"/>
+              </a:rPr>
+              <a:t>• Hipóteses concorrentes não confirmam falhas simultâneas</a:t>
+            </a:r>
+          </a:p>
+          <a:p>
+            <a:pPr>
+              <a:spcAft>
+                <a:spcPts val="1600"/>
+              </a:spcAft>
+            </a:pPr>
+            <a:r>
+              <a:rPr sz="2300" b="1">
+                <a:solidFill>
+                  <a:srgbClr val="1F2933"/>
+                </a:solidFill>
+                <a:latin typeface="Segoe UI"/>
+              </a:rPr>
+              <a:t>• Extensão: um predicado de reparo para cada falha fornecida</a:t>
+            </a:r>
+          </a:p>
+          <a:p>
+            <a:pPr>
+              <a:spcAft>
+                <a:spcPts val="1600"/>
+              </a:spcAft>
+            </a:pPr>
+            <a:r>
+              <a:rPr sz="2300" b="1">
+                <a:solidFill>
+                  <a:srgbClr val="1F2933"/>
+                </a:solidFill>
+                <a:latin typeface="Segoe UI"/>
+              </a:rPr>
+              <a:t>• Só verificar e encerrar após resolver todas as falhas do escopo</a:t>
+            </a:r>
+          </a:p>
+          <a:p>
+            <a:pPr>
+              <a:spcAft>
+                <a:spcPts val="1600"/>
+              </a:spcAft>
+            </a:pPr>
+            <a:r>
+              <a:rPr sz="2300" b="1">
+                <a:solidFill>
+                  <a:srgbClr val="1F2933"/>
+                </a:solidFill>
+                <a:latin typeface="Segoe UI"/>
+              </a:rPr>
+              <a:t>• Validar a extensão separadamente; resultados valem para o modelo</a:t>
             </a:r>
           </a:p>
         </p:txBody>

</xml_diff>